<commit_message>
Correção nos templates e adição do placeholder PRAZO
</commit_message>
<xml_diff>
--- a/templates/duo.pptx
+++ b/templates/duo.pptx
@@ -343,7 +343,7 @@
             <a:fld id="{1D8BD707-D9CF-40AE-B4C6-C98DA3205C09}" type="datetimeFigureOut">
               <a:rPr lang="en-US" smtClean="0"/>
               <a:pPr/>
-              <a:t>6/23/2026</a:t>
+              <a:t>6/26/2026</a:t>
             </a:fld>
             <a:endParaRPr lang="en-US"/>
           </a:p>
@@ -508,7 +508,7 @@
             <a:fld id="{1D8BD707-D9CF-40AE-B4C6-C98DA3205C09}" type="datetimeFigureOut">
               <a:rPr lang="en-US" smtClean="0"/>
               <a:pPr/>
-              <a:t>6/23/2026</a:t>
+              <a:t>6/26/2026</a:t>
             </a:fld>
             <a:endParaRPr lang="en-US"/>
           </a:p>
@@ -683,7 +683,7 @@
             <a:fld id="{1D8BD707-D9CF-40AE-B4C6-C98DA3205C09}" type="datetimeFigureOut">
               <a:rPr lang="en-US" smtClean="0"/>
               <a:pPr/>
-              <a:t>6/23/2026</a:t>
+              <a:t>6/26/2026</a:t>
             </a:fld>
             <a:endParaRPr lang="en-US"/>
           </a:p>
@@ -848,7 +848,7 @@
             <a:fld id="{1D8BD707-D9CF-40AE-B4C6-C98DA3205C09}" type="datetimeFigureOut">
               <a:rPr lang="en-US" smtClean="0"/>
               <a:pPr/>
-              <a:t>6/23/2026</a:t>
+              <a:t>6/26/2026</a:t>
             </a:fld>
             <a:endParaRPr lang="en-US"/>
           </a:p>
@@ -1090,7 +1090,7 @@
             <a:fld id="{1D8BD707-D9CF-40AE-B4C6-C98DA3205C09}" type="datetimeFigureOut">
               <a:rPr lang="en-US" smtClean="0"/>
               <a:pPr/>
-              <a:t>6/23/2026</a:t>
+              <a:t>6/26/2026</a:t>
             </a:fld>
             <a:endParaRPr lang="en-US"/>
           </a:p>
@@ -1372,7 +1372,7 @@
             <a:fld id="{1D8BD707-D9CF-40AE-B4C6-C98DA3205C09}" type="datetimeFigureOut">
               <a:rPr lang="en-US" smtClean="0"/>
               <a:pPr/>
-              <a:t>6/23/2026</a:t>
+              <a:t>6/26/2026</a:t>
             </a:fld>
             <a:endParaRPr lang="en-US"/>
           </a:p>
@@ -1788,7 +1788,7 @@
             <a:fld id="{1D8BD707-D9CF-40AE-B4C6-C98DA3205C09}" type="datetimeFigureOut">
               <a:rPr lang="en-US" smtClean="0"/>
               <a:pPr/>
-              <a:t>6/23/2026</a:t>
+              <a:t>6/26/2026</a:t>
             </a:fld>
             <a:endParaRPr lang="en-US"/>
           </a:p>
@@ -1902,7 +1902,7 @@
             <a:fld id="{1D8BD707-D9CF-40AE-B4C6-C98DA3205C09}" type="datetimeFigureOut">
               <a:rPr lang="en-US" smtClean="0"/>
               <a:pPr/>
-              <a:t>6/23/2026</a:t>
+              <a:t>6/26/2026</a:t>
             </a:fld>
             <a:endParaRPr lang="en-US"/>
           </a:p>
@@ -1994,7 +1994,7 @@
             <a:fld id="{1D8BD707-D9CF-40AE-B4C6-C98DA3205C09}" type="datetimeFigureOut">
               <a:rPr lang="en-US" smtClean="0"/>
               <a:pPr/>
-              <a:t>6/23/2026</a:t>
+              <a:t>6/26/2026</a:t>
             </a:fld>
             <a:endParaRPr lang="en-US"/>
           </a:p>
@@ -2266,7 +2266,7 @@
             <a:fld id="{1D8BD707-D9CF-40AE-B4C6-C98DA3205C09}" type="datetimeFigureOut">
               <a:rPr lang="en-US" smtClean="0"/>
               <a:pPr/>
-              <a:t>6/23/2026</a:t>
+              <a:t>6/26/2026</a:t>
             </a:fld>
             <a:endParaRPr lang="en-US"/>
           </a:p>
@@ -2515,7 +2515,7 @@
             <a:fld id="{1D8BD707-D9CF-40AE-B4C6-C98DA3205C09}" type="datetimeFigureOut">
               <a:rPr lang="en-US" smtClean="0"/>
               <a:pPr/>
-              <a:t>6/23/2026</a:t>
+              <a:t>6/26/2026</a:t>
             </a:fld>
             <a:endParaRPr lang="en-US"/>
           </a:p>
@@ -2723,7 +2723,7 @@
             <a:fld id="{1D8BD707-D9CF-40AE-B4C6-C98DA3205C09}" type="datetimeFigureOut">
               <a:rPr lang="en-US" smtClean="0"/>
               <a:pPr/>
-              <a:t>6/23/2026</a:t>
+              <a:t>6/26/2026</a:t>
             </a:fld>
             <a:endParaRPr lang="en-US"/>
           </a:p>
@@ -3343,7 +3343,7 @@
         <p:spPr>
           <a:xfrm>
             <a:off x="2897064" y="5525788"/>
-            <a:ext cx="4345068" cy="573746"/>
+            <a:ext cx="4345068" cy="534826"/>
           </a:xfrm>
           <a:prstGeom prst="rect">
             <a:avLst/>
@@ -3361,7 +3361,7 @@
               </a:lnSpc>
             </a:pPr>
             <a:r>
-              <a:rPr lang="en-US" sz="3300" b="1" dirty="0">
+              <a:rPr lang="en-US" sz="2500" b="1" dirty="0">
                 <a:solidFill>
                   <a:srgbClr val="000000"/>
                 </a:solidFill>
@@ -9902,7 +9902,7 @@
         <p:spPr>
           <a:xfrm>
             <a:off x="5578684" y="2993443"/>
-            <a:ext cx="3817902" cy="548130"/>
+            <a:ext cx="3817902" cy="505972"/>
           </a:xfrm>
           <a:prstGeom prst="rect">
             <a:avLst/>
@@ -9920,7 +9920,7 @@
               </a:lnSpc>
             </a:pPr>
             <a:r>
-              <a:rPr lang="en-US" sz="3170" b="1" dirty="0">
+              <a:rPr lang="en-US" sz="2500" b="1" dirty="0">
                 <a:solidFill>
                   <a:srgbClr val="FFFFFF"/>
                 </a:solidFill>
@@ -10225,7 +10225,7 @@
                 <a:cs typeface="Open Sans Bold Italics"/>
                 <a:sym typeface="Open Sans Bold Italics"/>
               </a:rPr>
-              <a:t>: 60 meses.</a:t>
+              <a:t>: [PRAZO]</a:t>
             </a:r>
           </a:p>
           <a:p>

</xml_diff>